<commit_message>
Final: remove screenshots, update todo, regenerate PPT
</commit_message>
<xml_diff>
--- a/Personal_CS_Coach_答辩PPT.pptx
+++ b/Personal_CS_Coach_答辩PPT.pptx
@@ -8657,128 +8657,7 @@
       </p:sp>
       <p:sp>
         <p:nvSpPr>
-          <p:cNvPr id="12" name="Rectangle 11"/>
-          <p:cNvSpPr/>
-          <p:nvPr/>
-        </p:nvSpPr>
-        <p:spPr>
-          <a:xfrm>
-            <a:off x="548640" y="5715000"/>
-            <a:ext cx="11064240" cy="731520"/>
-          </a:xfrm>
-          <a:prstGeom prst="rect">
-            <a:avLst/>
-          </a:prstGeom>
-          <a:solidFill>
-            <a:srgbClr val="161B22"/>
-          </a:solidFill>
-          <a:ln>
-            <a:noFill/>
-          </a:ln>
-        </p:spPr>
-        <p:style>
-          <a:lnRef idx="1">
-            <a:schemeClr val="accent1"/>
-          </a:lnRef>
-          <a:fillRef idx="3">
-            <a:schemeClr val="accent1"/>
-          </a:fillRef>
-          <a:effectRef idx="2">
-            <a:schemeClr val="accent1"/>
-          </a:effectRef>
-          <a:fontRef idx="minor">
-            <a:schemeClr val="lt1"/>
-          </a:fontRef>
-        </p:style>
-        <p:txBody>
-          <a:bodyPr rtlCol="0" anchor="ctr"/>
-          <a:lstStyle/>
-          <a:p>
-            <a:pPr algn="ctr"/>
-          </a:p>
-        </p:txBody>
-      </p:sp>
-      <p:sp>
-        <p:nvSpPr>
-          <p:cNvPr id="13" name="Rectangle 12"/>
-          <p:cNvSpPr/>
-          <p:nvPr/>
-        </p:nvSpPr>
-        <p:spPr>
-          <a:xfrm>
-            <a:off x="548640" y="5715000"/>
-            <a:ext cx="11064240" cy="22860"/>
-          </a:xfrm>
-          <a:prstGeom prst="rect">
-            <a:avLst/>
-          </a:prstGeom>
-          <a:solidFill>
-            <a:srgbClr val="58A6FF"/>
-          </a:solidFill>
-          <a:ln>
-            <a:noFill/>
-          </a:ln>
-        </p:spPr>
-        <p:style>
-          <a:lnRef idx="1">
-            <a:schemeClr val="accent1"/>
-          </a:lnRef>
-          <a:fillRef idx="3">
-            <a:schemeClr val="accent1"/>
-          </a:fillRef>
-          <a:effectRef idx="2">
-            <a:schemeClr val="accent1"/>
-          </a:effectRef>
-          <a:fontRef idx="minor">
-            <a:schemeClr val="lt1"/>
-          </a:fontRef>
-        </p:style>
-        <p:txBody>
-          <a:bodyPr rtlCol="0" anchor="ctr"/>
-          <a:lstStyle/>
-          <a:p>
-            <a:pPr algn="ctr"/>
-          </a:p>
-        </p:txBody>
-      </p:sp>
-      <p:sp>
-        <p:nvSpPr>
-          <p:cNvPr id="14" name="TextBox 13"/>
-          <p:cNvSpPr txBox="1"/>
-          <p:nvPr/>
-        </p:nvSpPr>
-        <p:spPr>
-          <a:xfrm>
-            <a:off x="685800" y="5806440"/>
-            <a:ext cx="10789920" cy="457200"/>
-          </a:xfrm>
-          <a:prstGeom prst="rect">
-            <a:avLst/>
-          </a:prstGeom>
-          <a:noFill/>
-        </p:spPr>
-        <p:txBody>
-          <a:bodyPr wrap="square">
-            <a:spAutoFit/>
-          </a:bodyPr>
-          <a:lstStyle/>
-          <a:p>
-            <a:pPr algn="ctr">
-              <a:defRPr sz="1200" b="0">
-                <a:solidFill>
-                  <a:srgbClr val="8B949E"/>
-                </a:solidFill>
-              </a:defRPr>
-            </a:pPr>
-            <a:r>
-              <a:t>📸 CS2 比赛画面 / 现有竞品对比（视频演示：0:00-0:30）</a:t>
-            </a:r>
-          </a:p>
-        </p:txBody>
-      </p:sp>
-      <p:sp>
-        <p:nvSpPr>
-          <p:cNvPr id="15" name="TextBox 14"/>
+          <p:cNvPr id="12" name="TextBox 11"/>
           <p:cNvSpPr txBox="1"/>
           <p:nvPr/>
         </p:nvSpPr>
@@ -8813,7 +8692,7 @@
       </p:sp>
       <p:sp>
         <p:nvSpPr>
-          <p:cNvPr id="16" name="TextBox 15"/>
+          <p:cNvPr id="13" name="TextBox 12"/>
           <p:cNvSpPr txBox="1"/>
           <p:nvPr/>
         </p:nvSpPr>
@@ -12456,8 +12335,86 @@
         </p:nvSpPr>
         <p:spPr>
           <a:xfrm>
-            <a:off x="457200" y="4572000"/>
-            <a:ext cx="3383280" cy="1371600"/>
+            <a:off x="457200" y="6035040"/>
+            <a:ext cx="3383280" cy="274320"/>
+          </a:xfrm>
+          <a:prstGeom prst="rect">
+            <a:avLst/>
+          </a:prstGeom>
+          <a:solidFill>
+            <a:srgbClr val="58A6FF"/>
+          </a:solidFill>
+          <a:ln>
+            <a:noFill/>
+          </a:ln>
+        </p:spPr>
+        <p:style>
+          <a:lnRef idx="1">
+            <a:schemeClr val="accent1"/>
+          </a:lnRef>
+          <a:fillRef idx="3">
+            <a:schemeClr val="accent1"/>
+          </a:fillRef>
+          <a:effectRef idx="2">
+            <a:schemeClr val="accent1"/>
+          </a:effectRef>
+          <a:fontRef idx="minor">
+            <a:schemeClr val="lt1"/>
+          </a:fontRef>
+        </p:style>
+        <p:txBody>
+          <a:bodyPr rtlCol="0" anchor="ctr"/>
+          <a:lstStyle/>
+          <a:p>
+            <a:pPr algn="ctr"/>
+          </a:p>
+        </p:txBody>
+      </p:sp>
+      <p:sp>
+        <p:nvSpPr>
+          <p:cNvPr id="8" name="TextBox 7"/>
+          <p:cNvSpPr txBox="1"/>
+          <p:nvPr/>
+        </p:nvSpPr>
+        <p:spPr>
+          <a:xfrm>
+            <a:off x="594360" y="6080760"/>
+            <a:ext cx="3108960" cy="182880"/>
+          </a:xfrm>
+          <a:prstGeom prst="rect">
+            <a:avLst/>
+          </a:prstGeom>
+          <a:noFill/>
+        </p:spPr>
+        <p:txBody>
+          <a:bodyPr wrap="square">
+            <a:spAutoFit/>
+          </a:bodyPr>
+          <a:lstStyle/>
+          <a:p>
+            <a:pPr algn="ctr">
+              <a:defRPr sz="900" b="0">
+                <a:solidFill>
+                  <a:srgbClr val="0D1117"/>
+                </a:solidFill>
+              </a:defRPr>
+            </a:pPr>
+            <a:r>
+              <a:t>📹 视频 0:30</a:t>
+            </a:r>
+          </a:p>
+        </p:txBody>
+      </p:sp>
+      <p:sp>
+        <p:nvSpPr>
+          <p:cNvPr id="9" name="Rectangle 8"/>
+          <p:cNvSpPr/>
+          <p:nvPr/>
+        </p:nvSpPr>
+        <p:spPr>
+          <a:xfrm>
+            <a:off x="4206240" y="1280160"/>
+            <a:ext cx="3657600" cy="5029200"/>
           </a:xfrm>
           <a:prstGeom prst="rect">
             <a:avLst/>
@@ -12493,14 +12450,96 @@
       </p:sp>
       <p:sp>
         <p:nvSpPr>
-          <p:cNvPr id="8" name="Rectangle 7"/>
+          <p:cNvPr id="10" name="TextBox 9"/>
+          <p:cNvSpPr txBox="1"/>
+          <p:nvPr/>
+        </p:nvSpPr>
+        <p:spPr>
+          <a:xfrm>
+            <a:off x="4389120" y="1417320"/>
+            <a:ext cx="3291840" cy="457200"/>
+          </a:xfrm>
+          <a:prstGeom prst="rect">
+            <a:avLst/>
+          </a:prstGeom>
+          <a:noFill/>
+        </p:spPr>
+        <p:txBody>
+          <a:bodyPr wrap="square">
+            <a:spAutoFit/>
+          </a:bodyPr>
+          <a:lstStyle/>
+          <a:p>
+            <a:pPr algn="l">
+              <a:defRPr sz="1400" b="1">
+                <a:solidFill>
+                  <a:srgbClr val="58A6FF"/>
+                </a:solidFill>
+              </a:defRPr>
+            </a:pPr>
+            <a:r>
+              <a:t>📐 战术编辑器</a:t>
+            </a:r>
+          </a:p>
+        </p:txBody>
+      </p:sp>
+      <p:sp>
+        <p:nvSpPr>
+          <p:cNvPr id="11" name="TextBox 10"/>
+          <p:cNvSpPr txBox="1"/>
+          <p:nvPr/>
+        </p:nvSpPr>
+        <p:spPr>
+          <a:xfrm>
+            <a:off x="4389120" y="1920240"/>
+            <a:ext cx="3291840" cy="2560320"/>
+          </a:xfrm>
+          <a:prstGeom prst="rect">
+            <a:avLst/>
+          </a:prstGeom>
+          <a:noFill/>
+        </p:spPr>
+        <p:txBody>
+          <a:bodyPr wrap="square">
+            <a:spAutoFit/>
+          </a:bodyPr>
+          <a:lstStyle/>
+          <a:p>
+            <a:pPr algn="l">
+              <a:defRPr sz="1100" b="0">
+                <a:solidFill>
+                  <a:srgbClr val="8B949E"/>
+                </a:solidFill>
+              </a:defRPr>
+            </a:pPr>
+            <a:r>
+              <a:t>拖拽绘图 + 标记拖动</a:t>
+            </a:r>
+            <a:br/>
+            <a:r>
+              <a:t>7 种画笔（含道具）</a:t>
+            </a:r>
+            <a:br/>
+            <a:r>
+              <a:t>Agent 评估雷达图</a:t>
+            </a:r>
+            <a:br/>
+            <a:r>
+              <a:t>优化对比弹窗</a:t>
+            </a:r>
+          </a:p>
+        </p:txBody>
+      </p:sp>
+      <p:sp>
+        <p:nvSpPr>
+          <p:cNvPr id="12" name="Rectangle 11"/>
           <p:cNvSpPr/>
           <p:nvPr/>
         </p:nvSpPr>
         <p:spPr>
           <a:xfrm>
-            <a:off x="457200" y="4572000"/>
-            <a:ext cx="3383280" cy="22860"/>
+            <a:off x="4343400" y="6035040"/>
+            <a:ext cx="3383280" cy="274320"/>
           </a:xfrm>
           <a:prstGeom prst="rect">
             <a:avLst/>
@@ -12536,14 +12575,14 @@
       </p:sp>
       <p:sp>
         <p:nvSpPr>
-          <p:cNvPr id="9" name="TextBox 8"/>
-          <p:cNvSpPr txBox="1"/>
-          <p:nvPr/>
-        </p:nvSpPr>
-        <p:spPr>
-          <a:xfrm>
-            <a:off x="594360" y="4983480"/>
-            <a:ext cx="3108960" cy="457200"/>
+          <p:cNvPr id="13" name="TextBox 12"/>
+          <p:cNvSpPr txBox="1"/>
+          <p:nvPr/>
+        </p:nvSpPr>
+        <p:spPr>
+          <a:xfrm>
+            <a:off x="4480560" y="6080760"/>
+            <a:ext cx="3108960" cy="182880"/>
           </a:xfrm>
           <a:prstGeom prst="rect">
             <a:avLst/>
@@ -12557,27 +12596,152 @@
           <a:lstStyle/>
           <a:p>
             <a:pPr algn="ctr">
-              <a:defRPr sz="1200" b="0">
+              <a:defRPr sz="900" b="0">
+                <a:solidFill>
+                  <a:srgbClr val="0D1117"/>
+                </a:solidFill>
+              </a:defRPr>
+            </a:pPr>
+            <a:r>
+              <a:t>📹 视频 0:30-2:00</a:t>
+            </a:r>
+          </a:p>
+        </p:txBody>
+      </p:sp>
+      <p:sp>
+        <p:nvSpPr>
+          <p:cNvPr id="14" name="Rectangle 13"/>
+          <p:cNvSpPr/>
+          <p:nvPr/>
+        </p:nvSpPr>
+        <p:spPr>
+          <a:xfrm>
+            <a:off x="8092440" y="1280160"/>
+            <a:ext cx="3657600" cy="5029200"/>
+          </a:xfrm>
+          <a:prstGeom prst="rect">
+            <a:avLst/>
+          </a:prstGeom>
+          <a:solidFill>
+            <a:srgbClr val="161B22"/>
+          </a:solidFill>
+          <a:ln>
+            <a:noFill/>
+          </a:ln>
+        </p:spPr>
+        <p:style>
+          <a:lnRef idx="1">
+            <a:schemeClr val="accent1"/>
+          </a:lnRef>
+          <a:fillRef idx="3">
+            <a:schemeClr val="accent1"/>
+          </a:fillRef>
+          <a:effectRef idx="2">
+            <a:schemeClr val="accent1"/>
+          </a:effectRef>
+          <a:fontRef idx="minor">
+            <a:schemeClr val="lt1"/>
+          </a:fontRef>
+        </p:style>
+        <p:txBody>
+          <a:bodyPr rtlCol="0" anchor="ctr"/>
+          <a:lstStyle/>
+          <a:p>
+            <a:pPr algn="ctr"/>
+          </a:p>
+        </p:txBody>
+      </p:sp>
+      <p:sp>
+        <p:nvSpPr>
+          <p:cNvPr id="15" name="TextBox 14"/>
+          <p:cNvSpPr txBox="1"/>
+          <p:nvPr/>
+        </p:nvSpPr>
+        <p:spPr>
+          <a:xfrm>
+            <a:off x="8275320" y="1417320"/>
+            <a:ext cx="3291840" cy="457200"/>
+          </a:xfrm>
+          <a:prstGeom prst="rect">
+            <a:avLst/>
+          </a:prstGeom>
+          <a:noFill/>
+        </p:spPr>
+        <p:txBody>
+          <a:bodyPr wrap="square">
+            <a:spAutoFit/>
+          </a:bodyPr>
+          <a:lstStyle/>
+          <a:p>
+            <a:pPr algn="l">
+              <a:defRPr sz="1400" b="1">
+                <a:solidFill>
+                  <a:srgbClr val="58A6FF"/>
+                </a:solidFill>
+              </a:defRPr>
+            </a:pPr>
+            <a:r>
+              <a:t>🎮 比赛仪表盘</a:t>
+            </a:r>
+          </a:p>
+        </p:txBody>
+      </p:sp>
+      <p:sp>
+        <p:nvSpPr>
+          <p:cNvPr id="16" name="TextBox 15"/>
+          <p:cNvSpPr txBox="1"/>
+          <p:nvPr/>
+        </p:nvSpPr>
+        <p:spPr>
+          <a:xfrm>
+            <a:off x="8275320" y="1920240"/>
+            <a:ext cx="3291840" cy="2560320"/>
+          </a:xfrm>
+          <a:prstGeom prst="rect">
+            <a:avLst/>
+          </a:prstGeom>
+          <a:noFill/>
+        </p:spPr>
+        <p:txBody>
+          <a:bodyPr wrap="square">
+            <a:spAutoFit/>
+          </a:bodyPr>
+          <a:lstStyle/>
+          <a:p>
+            <a:pPr algn="l">
+              <a:defRPr sz="1100" b="0">
                 <a:solidFill>
                   <a:srgbClr val="8B949E"/>
                 </a:solidFill>
               </a:defRPr>
             </a:pPr>
             <a:r>
-              <a:t>📸 截图区域</a:t>
-            </a:r>
-          </a:p>
-        </p:txBody>
-      </p:sp>
-      <p:sp>
-        <p:nvSpPr>
-          <p:cNvPr id="10" name="Rectangle 9"/>
+              <a:t>第二屏幕实时标注</a:t>
+            </a:r>
+            <a:br/>
+            <a:r>
+              <a:t>CT/T 颜色区分</a:t>
+            </a:r>
+            <a:br/>
+            <a:r>
+              <a:t>Agent 分析弹窗</a:t>
+            </a:r>
+            <a:br/>
+            <a:r>
+              <a:t>一键采纳 Agent 建议</a:t>
+            </a:r>
+          </a:p>
+        </p:txBody>
+      </p:sp>
+      <p:sp>
+        <p:nvSpPr>
+          <p:cNvPr id="17" name="Rectangle 16"/>
           <p:cNvSpPr/>
           <p:nvPr/>
         </p:nvSpPr>
         <p:spPr>
           <a:xfrm>
-            <a:off x="457200" y="6035040"/>
+            <a:off x="8229600" y="6035040"/>
             <a:ext cx="3383280" cy="274320"/>
           </a:xfrm>
           <a:prstGeom prst="rect">
@@ -12614,13 +12778,13 @@
       </p:sp>
       <p:sp>
         <p:nvSpPr>
-          <p:cNvPr id="11" name="TextBox 10"/>
-          <p:cNvSpPr txBox="1"/>
-          <p:nvPr/>
-        </p:nvSpPr>
-        <p:spPr>
-          <a:xfrm>
-            <a:off x="594360" y="6080760"/>
+          <p:cNvPr id="18" name="TextBox 17"/>
+          <p:cNvSpPr txBox="1"/>
+          <p:nvPr/>
+        </p:nvSpPr>
+        <p:spPr>
+          <a:xfrm>
+            <a:off x="8366760" y="6080760"/>
             <a:ext cx="3108960" cy="182880"/>
           </a:xfrm>
           <a:prstGeom prst="rect">
@@ -12642,662 +12806,14 @@
               </a:defRPr>
             </a:pPr>
             <a:r>
-              <a:t>📹 视频 0:30</a:t>
-            </a:r>
-          </a:p>
-        </p:txBody>
-      </p:sp>
-      <p:sp>
-        <p:nvSpPr>
-          <p:cNvPr id="12" name="Rectangle 11"/>
-          <p:cNvSpPr/>
-          <p:nvPr/>
-        </p:nvSpPr>
-        <p:spPr>
-          <a:xfrm>
-            <a:off x="4206240" y="1280160"/>
-            <a:ext cx="3657600" cy="5029200"/>
-          </a:xfrm>
-          <a:prstGeom prst="rect">
-            <a:avLst/>
-          </a:prstGeom>
-          <a:solidFill>
-            <a:srgbClr val="161B22"/>
-          </a:solidFill>
-          <a:ln>
-            <a:noFill/>
-          </a:ln>
-        </p:spPr>
-        <p:style>
-          <a:lnRef idx="1">
-            <a:schemeClr val="accent1"/>
-          </a:lnRef>
-          <a:fillRef idx="3">
-            <a:schemeClr val="accent1"/>
-          </a:fillRef>
-          <a:effectRef idx="2">
-            <a:schemeClr val="accent1"/>
-          </a:effectRef>
-          <a:fontRef idx="minor">
-            <a:schemeClr val="lt1"/>
-          </a:fontRef>
-        </p:style>
-        <p:txBody>
-          <a:bodyPr rtlCol="0" anchor="ctr"/>
-          <a:lstStyle/>
-          <a:p>
-            <a:pPr algn="ctr"/>
-          </a:p>
-        </p:txBody>
-      </p:sp>
-      <p:sp>
-        <p:nvSpPr>
-          <p:cNvPr id="13" name="TextBox 12"/>
-          <p:cNvSpPr txBox="1"/>
-          <p:nvPr/>
-        </p:nvSpPr>
-        <p:spPr>
-          <a:xfrm>
-            <a:off x="4389120" y="1417320"/>
-            <a:ext cx="3291840" cy="457200"/>
-          </a:xfrm>
-          <a:prstGeom prst="rect">
-            <a:avLst/>
-          </a:prstGeom>
-          <a:noFill/>
-        </p:spPr>
-        <p:txBody>
-          <a:bodyPr wrap="square">
-            <a:spAutoFit/>
-          </a:bodyPr>
-          <a:lstStyle/>
-          <a:p>
-            <a:pPr algn="l">
-              <a:defRPr sz="1400" b="1">
-                <a:solidFill>
-                  <a:srgbClr val="58A6FF"/>
-                </a:solidFill>
-              </a:defRPr>
-            </a:pPr>
-            <a:r>
-              <a:t>📐 战术编辑器</a:t>
-            </a:r>
-          </a:p>
-        </p:txBody>
-      </p:sp>
-      <p:sp>
-        <p:nvSpPr>
-          <p:cNvPr id="14" name="TextBox 13"/>
-          <p:cNvSpPr txBox="1"/>
-          <p:nvPr/>
-        </p:nvSpPr>
-        <p:spPr>
-          <a:xfrm>
-            <a:off x="4389120" y="1920240"/>
-            <a:ext cx="3291840" cy="2560320"/>
-          </a:xfrm>
-          <a:prstGeom prst="rect">
-            <a:avLst/>
-          </a:prstGeom>
-          <a:noFill/>
-        </p:spPr>
-        <p:txBody>
-          <a:bodyPr wrap="square">
-            <a:spAutoFit/>
-          </a:bodyPr>
-          <a:lstStyle/>
-          <a:p>
-            <a:pPr algn="l">
-              <a:defRPr sz="1100" b="0">
-                <a:solidFill>
-                  <a:srgbClr val="8B949E"/>
-                </a:solidFill>
-              </a:defRPr>
-            </a:pPr>
-            <a:r>
-              <a:t>拖拽绘图 + 标记拖动</a:t>
-            </a:r>
-            <a:br/>
-            <a:r>
-              <a:t>7 种画笔（含道具）</a:t>
-            </a:r>
-            <a:br/>
-            <a:r>
-              <a:t>Agent 评估雷达图</a:t>
-            </a:r>
-            <a:br/>
-            <a:r>
-              <a:t>优化对比弹窗</a:t>
-            </a:r>
-          </a:p>
-        </p:txBody>
-      </p:sp>
-      <p:sp>
-        <p:nvSpPr>
-          <p:cNvPr id="15" name="Rectangle 14"/>
-          <p:cNvSpPr/>
-          <p:nvPr/>
-        </p:nvSpPr>
-        <p:spPr>
-          <a:xfrm>
-            <a:off x="4343400" y="4572000"/>
-            <a:ext cx="3383280" cy="1371600"/>
-          </a:xfrm>
-          <a:prstGeom prst="rect">
-            <a:avLst/>
-          </a:prstGeom>
-          <a:solidFill>
-            <a:srgbClr val="161B22"/>
-          </a:solidFill>
-          <a:ln>
-            <a:noFill/>
-          </a:ln>
-        </p:spPr>
-        <p:style>
-          <a:lnRef idx="1">
-            <a:schemeClr val="accent1"/>
-          </a:lnRef>
-          <a:fillRef idx="3">
-            <a:schemeClr val="accent1"/>
-          </a:fillRef>
-          <a:effectRef idx="2">
-            <a:schemeClr val="accent1"/>
-          </a:effectRef>
-          <a:fontRef idx="minor">
-            <a:schemeClr val="lt1"/>
-          </a:fontRef>
-        </p:style>
-        <p:txBody>
-          <a:bodyPr rtlCol="0" anchor="ctr"/>
-          <a:lstStyle/>
-          <a:p>
-            <a:pPr algn="ctr"/>
-          </a:p>
-        </p:txBody>
-      </p:sp>
-      <p:sp>
-        <p:nvSpPr>
-          <p:cNvPr id="16" name="Rectangle 15"/>
-          <p:cNvSpPr/>
-          <p:nvPr/>
-        </p:nvSpPr>
-        <p:spPr>
-          <a:xfrm>
-            <a:off x="4343400" y="4572000"/>
-            <a:ext cx="3383280" cy="22860"/>
-          </a:xfrm>
-          <a:prstGeom prst="rect">
-            <a:avLst/>
-          </a:prstGeom>
-          <a:solidFill>
-            <a:srgbClr val="58A6FF"/>
-          </a:solidFill>
-          <a:ln>
-            <a:noFill/>
-          </a:ln>
-        </p:spPr>
-        <p:style>
-          <a:lnRef idx="1">
-            <a:schemeClr val="accent1"/>
-          </a:lnRef>
-          <a:fillRef idx="3">
-            <a:schemeClr val="accent1"/>
-          </a:fillRef>
-          <a:effectRef idx="2">
-            <a:schemeClr val="accent1"/>
-          </a:effectRef>
-          <a:fontRef idx="minor">
-            <a:schemeClr val="lt1"/>
-          </a:fontRef>
-        </p:style>
-        <p:txBody>
-          <a:bodyPr rtlCol="0" anchor="ctr"/>
-          <a:lstStyle/>
-          <a:p>
-            <a:pPr algn="ctr"/>
-          </a:p>
-        </p:txBody>
-      </p:sp>
-      <p:sp>
-        <p:nvSpPr>
-          <p:cNvPr id="17" name="TextBox 16"/>
-          <p:cNvSpPr txBox="1"/>
-          <p:nvPr/>
-        </p:nvSpPr>
-        <p:spPr>
-          <a:xfrm>
-            <a:off x="4480560" y="4983480"/>
-            <a:ext cx="3108960" cy="457200"/>
-          </a:xfrm>
-          <a:prstGeom prst="rect">
-            <a:avLst/>
-          </a:prstGeom>
-          <a:noFill/>
-        </p:spPr>
-        <p:txBody>
-          <a:bodyPr wrap="square">
-            <a:spAutoFit/>
-          </a:bodyPr>
-          <a:lstStyle/>
-          <a:p>
-            <a:pPr algn="ctr">
-              <a:defRPr sz="1200" b="0">
-                <a:solidFill>
-                  <a:srgbClr val="8B949E"/>
-                </a:solidFill>
-              </a:defRPr>
-            </a:pPr>
-            <a:r>
-              <a:t>📸 截图区域</a:t>
-            </a:r>
-          </a:p>
-        </p:txBody>
-      </p:sp>
-      <p:sp>
-        <p:nvSpPr>
-          <p:cNvPr id="18" name="Rectangle 17"/>
-          <p:cNvSpPr/>
-          <p:nvPr/>
-        </p:nvSpPr>
-        <p:spPr>
-          <a:xfrm>
-            <a:off x="4343400" y="6035040"/>
-            <a:ext cx="3383280" cy="274320"/>
-          </a:xfrm>
-          <a:prstGeom prst="rect">
-            <a:avLst/>
-          </a:prstGeom>
-          <a:solidFill>
-            <a:srgbClr val="58A6FF"/>
-          </a:solidFill>
-          <a:ln>
-            <a:noFill/>
-          </a:ln>
-        </p:spPr>
-        <p:style>
-          <a:lnRef idx="1">
-            <a:schemeClr val="accent1"/>
-          </a:lnRef>
-          <a:fillRef idx="3">
-            <a:schemeClr val="accent1"/>
-          </a:fillRef>
-          <a:effectRef idx="2">
-            <a:schemeClr val="accent1"/>
-          </a:effectRef>
-          <a:fontRef idx="minor">
-            <a:schemeClr val="lt1"/>
-          </a:fontRef>
-        </p:style>
-        <p:txBody>
-          <a:bodyPr rtlCol="0" anchor="ctr"/>
-          <a:lstStyle/>
-          <a:p>
-            <a:pPr algn="ctr"/>
+              <a:t>📹 视频 2:00-5:30</a:t>
+            </a:r>
           </a:p>
         </p:txBody>
       </p:sp>
       <p:sp>
         <p:nvSpPr>
           <p:cNvPr id="19" name="TextBox 18"/>
-          <p:cNvSpPr txBox="1"/>
-          <p:nvPr/>
-        </p:nvSpPr>
-        <p:spPr>
-          <a:xfrm>
-            <a:off x="4480560" y="6080760"/>
-            <a:ext cx="3108960" cy="182880"/>
-          </a:xfrm>
-          <a:prstGeom prst="rect">
-            <a:avLst/>
-          </a:prstGeom>
-          <a:noFill/>
-        </p:spPr>
-        <p:txBody>
-          <a:bodyPr wrap="square">
-            <a:spAutoFit/>
-          </a:bodyPr>
-          <a:lstStyle/>
-          <a:p>
-            <a:pPr algn="ctr">
-              <a:defRPr sz="900" b="0">
-                <a:solidFill>
-                  <a:srgbClr val="0D1117"/>
-                </a:solidFill>
-              </a:defRPr>
-            </a:pPr>
-            <a:r>
-              <a:t>📹 视频 0:30-2:00</a:t>
-            </a:r>
-          </a:p>
-        </p:txBody>
-      </p:sp>
-      <p:sp>
-        <p:nvSpPr>
-          <p:cNvPr id="20" name="Rectangle 19"/>
-          <p:cNvSpPr/>
-          <p:nvPr/>
-        </p:nvSpPr>
-        <p:spPr>
-          <a:xfrm>
-            <a:off x="8092440" y="1280160"/>
-            <a:ext cx="3657600" cy="5029200"/>
-          </a:xfrm>
-          <a:prstGeom prst="rect">
-            <a:avLst/>
-          </a:prstGeom>
-          <a:solidFill>
-            <a:srgbClr val="161B22"/>
-          </a:solidFill>
-          <a:ln>
-            <a:noFill/>
-          </a:ln>
-        </p:spPr>
-        <p:style>
-          <a:lnRef idx="1">
-            <a:schemeClr val="accent1"/>
-          </a:lnRef>
-          <a:fillRef idx="3">
-            <a:schemeClr val="accent1"/>
-          </a:fillRef>
-          <a:effectRef idx="2">
-            <a:schemeClr val="accent1"/>
-          </a:effectRef>
-          <a:fontRef idx="minor">
-            <a:schemeClr val="lt1"/>
-          </a:fontRef>
-        </p:style>
-        <p:txBody>
-          <a:bodyPr rtlCol="0" anchor="ctr"/>
-          <a:lstStyle/>
-          <a:p>
-            <a:pPr algn="ctr"/>
-          </a:p>
-        </p:txBody>
-      </p:sp>
-      <p:sp>
-        <p:nvSpPr>
-          <p:cNvPr id="21" name="TextBox 20"/>
-          <p:cNvSpPr txBox="1"/>
-          <p:nvPr/>
-        </p:nvSpPr>
-        <p:spPr>
-          <a:xfrm>
-            <a:off x="8275320" y="1417320"/>
-            <a:ext cx="3291840" cy="457200"/>
-          </a:xfrm>
-          <a:prstGeom prst="rect">
-            <a:avLst/>
-          </a:prstGeom>
-          <a:noFill/>
-        </p:spPr>
-        <p:txBody>
-          <a:bodyPr wrap="square">
-            <a:spAutoFit/>
-          </a:bodyPr>
-          <a:lstStyle/>
-          <a:p>
-            <a:pPr algn="l">
-              <a:defRPr sz="1400" b="1">
-                <a:solidFill>
-                  <a:srgbClr val="58A6FF"/>
-                </a:solidFill>
-              </a:defRPr>
-            </a:pPr>
-            <a:r>
-              <a:t>🎮 比赛仪表盘</a:t>
-            </a:r>
-          </a:p>
-        </p:txBody>
-      </p:sp>
-      <p:sp>
-        <p:nvSpPr>
-          <p:cNvPr id="22" name="TextBox 21"/>
-          <p:cNvSpPr txBox="1"/>
-          <p:nvPr/>
-        </p:nvSpPr>
-        <p:spPr>
-          <a:xfrm>
-            <a:off x="8275320" y="1920240"/>
-            <a:ext cx="3291840" cy="2560320"/>
-          </a:xfrm>
-          <a:prstGeom prst="rect">
-            <a:avLst/>
-          </a:prstGeom>
-          <a:noFill/>
-        </p:spPr>
-        <p:txBody>
-          <a:bodyPr wrap="square">
-            <a:spAutoFit/>
-          </a:bodyPr>
-          <a:lstStyle/>
-          <a:p>
-            <a:pPr algn="l">
-              <a:defRPr sz="1100" b="0">
-                <a:solidFill>
-                  <a:srgbClr val="8B949E"/>
-                </a:solidFill>
-              </a:defRPr>
-            </a:pPr>
-            <a:r>
-              <a:t>第二屏幕实时标注</a:t>
-            </a:r>
-            <a:br/>
-            <a:r>
-              <a:t>CT/T 颜色区分</a:t>
-            </a:r>
-            <a:br/>
-            <a:r>
-              <a:t>Agent 分析弹窗</a:t>
-            </a:r>
-            <a:br/>
-            <a:r>
-              <a:t>一键采纳 Agent 建议</a:t>
-            </a:r>
-          </a:p>
-        </p:txBody>
-      </p:sp>
-      <p:sp>
-        <p:nvSpPr>
-          <p:cNvPr id="23" name="Rectangle 22"/>
-          <p:cNvSpPr/>
-          <p:nvPr/>
-        </p:nvSpPr>
-        <p:spPr>
-          <a:xfrm>
-            <a:off x="8229600" y="4572000"/>
-            <a:ext cx="3383280" cy="1371600"/>
-          </a:xfrm>
-          <a:prstGeom prst="rect">
-            <a:avLst/>
-          </a:prstGeom>
-          <a:solidFill>
-            <a:srgbClr val="161B22"/>
-          </a:solidFill>
-          <a:ln>
-            <a:noFill/>
-          </a:ln>
-        </p:spPr>
-        <p:style>
-          <a:lnRef idx="1">
-            <a:schemeClr val="accent1"/>
-          </a:lnRef>
-          <a:fillRef idx="3">
-            <a:schemeClr val="accent1"/>
-          </a:fillRef>
-          <a:effectRef idx="2">
-            <a:schemeClr val="accent1"/>
-          </a:effectRef>
-          <a:fontRef idx="minor">
-            <a:schemeClr val="lt1"/>
-          </a:fontRef>
-        </p:style>
-        <p:txBody>
-          <a:bodyPr rtlCol="0" anchor="ctr"/>
-          <a:lstStyle/>
-          <a:p>
-            <a:pPr algn="ctr"/>
-          </a:p>
-        </p:txBody>
-      </p:sp>
-      <p:sp>
-        <p:nvSpPr>
-          <p:cNvPr id="24" name="Rectangle 23"/>
-          <p:cNvSpPr/>
-          <p:nvPr/>
-        </p:nvSpPr>
-        <p:spPr>
-          <a:xfrm>
-            <a:off x="8229600" y="4572000"/>
-            <a:ext cx="3383280" cy="22860"/>
-          </a:xfrm>
-          <a:prstGeom prst="rect">
-            <a:avLst/>
-          </a:prstGeom>
-          <a:solidFill>
-            <a:srgbClr val="58A6FF"/>
-          </a:solidFill>
-          <a:ln>
-            <a:noFill/>
-          </a:ln>
-        </p:spPr>
-        <p:style>
-          <a:lnRef idx="1">
-            <a:schemeClr val="accent1"/>
-          </a:lnRef>
-          <a:fillRef idx="3">
-            <a:schemeClr val="accent1"/>
-          </a:fillRef>
-          <a:effectRef idx="2">
-            <a:schemeClr val="accent1"/>
-          </a:effectRef>
-          <a:fontRef idx="minor">
-            <a:schemeClr val="lt1"/>
-          </a:fontRef>
-        </p:style>
-        <p:txBody>
-          <a:bodyPr rtlCol="0" anchor="ctr"/>
-          <a:lstStyle/>
-          <a:p>
-            <a:pPr algn="ctr"/>
-          </a:p>
-        </p:txBody>
-      </p:sp>
-      <p:sp>
-        <p:nvSpPr>
-          <p:cNvPr id="25" name="TextBox 24"/>
-          <p:cNvSpPr txBox="1"/>
-          <p:nvPr/>
-        </p:nvSpPr>
-        <p:spPr>
-          <a:xfrm>
-            <a:off x="8366760" y="4983480"/>
-            <a:ext cx="3108960" cy="457200"/>
-          </a:xfrm>
-          <a:prstGeom prst="rect">
-            <a:avLst/>
-          </a:prstGeom>
-          <a:noFill/>
-        </p:spPr>
-        <p:txBody>
-          <a:bodyPr wrap="square">
-            <a:spAutoFit/>
-          </a:bodyPr>
-          <a:lstStyle/>
-          <a:p>
-            <a:pPr algn="ctr">
-              <a:defRPr sz="1200" b="0">
-                <a:solidFill>
-                  <a:srgbClr val="8B949E"/>
-                </a:solidFill>
-              </a:defRPr>
-            </a:pPr>
-            <a:r>
-              <a:t>📸 截图区域</a:t>
-            </a:r>
-          </a:p>
-        </p:txBody>
-      </p:sp>
-      <p:sp>
-        <p:nvSpPr>
-          <p:cNvPr id="26" name="Rectangle 25"/>
-          <p:cNvSpPr/>
-          <p:nvPr/>
-        </p:nvSpPr>
-        <p:spPr>
-          <a:xfrm>
-            <a:off x="8229600" y="6035040"/>
-            <a:ext cx="3383280" cy="274320"/>
-          </a:xfrm>
-          <a:prstGeom prst="rect">
-            <a:avLst/>
-          </a:prstGeom>
-          <a:solidFill>
-            <a:srgbClr val="58A6FF"/>
-          </a:solidFill>
-          <a:ln>
-            <a:noFill/>
-          </a:ln>
-        </p:spPr>
-        <p:style>
-          <a:lnRef idx="1">
-            <a:schemeClr val="accent1"/>
-          </a:lnRef>
-          <a:fillRef idx="3">
-            <a:schemeClr val="accent1"/>
-          </a:fillRef>
-          <a:effectRef idx="2">
-            <a:schemeClr val="accent1"/>
-          </a:effectRef>
-          <a:fontRef idx="minor">
-            <a:schemeClr val="lt1"/>
-          </a:fontRef>
-        </p:style>
-        <p:txBody>
-          <a:bodyPr rtlCol="0" anchor="ctr"/>
-          <a:lstStyle/>
-          <a:p>
-            <a:pPr algn="ctr"/>
-          </a:p>
-        </p:txBody>
-      </p:sp>
-      <p:sp>
-        <p:nvSpPr>
-          <p:cNvPr id="27" name="TextBox 26"/>
-          <p:cNvSpPr txBox="1"/>
-          <p:nvPr/>
-        </p:nvSpPr>
-        <p:spPr>
-          <a:xfrm>
-            <a:off x="8366760" y="6080760"/>
-            <a:ext cx="3108960" cy="182880"/>
-          </a:xfrm>
-          <a:prstGeom prst="rect">
-            <a:avLst/>
-          </a:prstGeom>
-          <a:noFill/>
-        </p:spPr>
-        <p:txBody>
-          <a:bodyPr wrap="square">
-            <a:spAutoFit/>
-          </a:bodyPr>
-          <a:lstStyle/>
-          <a:p>
-            <a:pPr algn="ctr">
-              <a:defRPr sz="900" b="0">
-                <a:solidFill>
-                  <a:srgbClr val="0D1117"/>
-                </a:solidFill>
-              </a:defRPr>
-            </a:pPr>
-            <a:r>
-              <a:t>📹 视频 2:00-5:30</a:t>
-            </a:r>
-          </a:p>
-        </p:txBody>
-      </p:sp>
-      <p:sp>
-        <p:nvSpPr>
-          <p:cNvPr id="28" name="TextBox 27"/>
           <p:cNvSpPr txBox="1"/>
           <p:nvPr/>
         </p:nvSpPr>
@@ -13332,7 +12848,7 @@
       </p:sp>
       <p:sp>
         <p:nvSpPr>
-          <p:cNvPr id="29" name="TextBox 28"/>
+          <p:cNvPr id="20" name="TextBox 19"/>
           <p:cNvSpPr txBox="1"/>
           <p:nvPr/>
         </p:nvSpPr>

</xml_diff>